<commit_message>
Restore top issues template preview
</commit_message>
<xml_diff>
--- a/examples/italy_progress_report/preview_replace_report.pptx
+++ b/examples/italy_progress_report/preview_replace_report.pptx
@@ -19737,7 +19737,7 @@
                 <a:cs typeface="Noto Sans SC"/>
                 <a:sym typeface="Noto Sans SC"/>
               </a:rPr>
-              <a:t>存在风险</a:t>
+              <a:t>需要关注</a:t>
             </a:r>
             <a:endParaRPr lang="en-US" sz="1100" dirty="0">
               <a:latin typeface="微软雅黑" panose="020B0503020204020204" pitchFamily="34" charset="-122"/>
@@ -21256,7 +21256,7 @@
                 <a:cs typeface="Noto Sans SC"/>
                 <a:sym typeface="Noto Sans SC"/>
               </a:rPr>
-              <a:t>项目进度13%，调测与验收任务持续进行。</a:t>
+              <a:t>项目处于进行中，交付任务与风险跟踪持续推进。</a:t>
             </a:r>
             <a:endParaRPr lang="en-US" dirty="0">
               <a:solidFill>
@@ -21350,7 +21350,7 @@
                 <a:cs typeface="Noto Sans SC"/>
                 <a:sym typeface="Noto Sans SC"/>
               </a:rPr>
-              <a:t>关键结论：项目进度缓慢，大量待分配任务，风险问题需尽快处理。</a:t>
+              <a:t>关键结论：整体推进中，延期任务需关注。</a:t>
             </a:r>
             <a:r>
               <a:rPr lang="en-US" altLang="zh-CN" sz="1200" b="0" i="0" u="none" strike="noStrike" dirty="0">
@@ -21511,7 +21511,7 @@
                 <a:ea typeface="微软雅黑" panose="020B0503020204020204" pitchFamily="34" charset="-122"/>
                 <a:sym typeface="Noto Sans SC"/>
               </a:rPr>
-              <a:t>本期完成前置学习、设计、安装及验收部分任务，调测与移交进行中。</a:t>
+              <a:t>本期完成部分设计、安装与调测任务推进。</a:t>
             </a:r>
             <a:endParaRPr lang="en-US" dirty="0">
               <a:solidFill>
@@ -21668,7 +21668,7 @@
                 <a:cs typeface="Noto Sans SC"/>
                 <a:sym typeface="Noto Sans SC"/>
               </a:rPr>
-              <a:t>本期成功关闭 0 个问题或风险，现有 7 个问题或风险在处理中。</a:t>
+              <a:t>本期成功关闭 0 个问题或风险，现有 9 个问题或风险在处理中。</a:t>
             </a:r>
             <a:r>
               <a:rPr lang="en-US" altLang="zh-CN" sz="1200" b="0" i="0" u="none" strike="noStrike" dirty="0">
@@ -36167,16 +36167,101 @@
           </a:p>
         </p:txBody>
       </p:sp>
+      <p:sp>
+        <p:nvSpPr>
+          <p:cNvPr id="19" name="milestone.delivery.background"/>
+          <p:cNvSpPr/>
+          <p:nvPr/>
+        </p:nvSpPr>
+        <p:spPr>
+          <a:xfrm>
+            <a:off x="655554" y="1152469"/>
+            <a:ext cx="10763017" cy="1116443"/>
+          </a:xfrm>
+          <a:prstGeom prst="roundRect">
+            <a:avLst>
+              <a:gd name="adj" fmla="val 3590"/>
+            </a:avLst>
+          </a:prstGeom>
+          <a:solidFill>
+            <a:schemeClr val="accent4">
+              <a:lumMod val="20000"/>
+              <a:lumOff val="80000"/>
+            </a:schemeClr>
+          </a:solidFill>
+          <a:ln cap="flat" cmpd="sng" algn="ctr">
+            <a:gradFill flip="none" rotWithShape="1">
+              <a:gsLst>
+                <a:gs pos="50000">
+                  <a:srgbClr val="FFFFFF">
+                    <a:alpha val="10000"/>
+                  </a:srgbClr>
+                </a:gs>
+                <a:gs pos="90000">
+                  <a:sysClr val="window" lastClr="FFFFFF">
+                    <a:alpha val="0"/>
+                  </a:sysClr>
+                </a:gs>
+                <a:gs pos="10000">
+                  <a:sysClr val="window" lastClr="FFFFFF">
+                    <a:alpha val="0"/>
+                  </a:sysClr>
+                </a:gs>
+                <a:gs pos="0">
+                  <a:sysClr val="windowText" lastClr="000000">
+                    <a:lumMod val="50000"/>
+                    <a:lumOff val="50000"/>
+                    <a:alpha val="50000"/>
+                  </a:sysClr>
+                </a:gs>
+                <a:gs pos="100000">
+                  <a:sysClr val="windowText" lastClr="000000">
+                    <a:lumMod val="50000"/>
+                    <a:lumOff val="50000"/>
+                    <a:alpha val="50000"/>
+                  </a:sysClr>
+                </a:gs>
+              </a:gsLst>
+              <a:lin ang="5400000" scaled="0"/>
+              <a:tileRect/>
+            </a:gradFill>
+            <a:prstDash val="solid"/>
+            <a:miter lim="800000"/>
+            <a:headEnd type="none" w="med" len="med"/>
+            <a:tailEnd type="none" w="med" len="med"/>
+          </a:ln>
+          <a:effectLst/>
+        </p:spPr>
+        <p:style>
+          <a:lnRef idx="1">
+            <a:schemeClr val="accent1"/>
+          </a:lnRef>
+          <a:fillRef idx="3">
+            <a:schemeClr val="accent1"/>
+          </a:fillRef>
+          <a:effectRef idx="2">
+            <a:schemeClr val="accent1"/>
+          </a:effectRef>
+          <a:fontRef idx="minor">
+            <a:schemeClr val="lt1"/>
+          </a:fontRef>
+        </p:style>
+        <p:txBody>
+          <a:bodyPr rtlCol="0" anchor="ctr"/>
+          <a:lstStyle/>
+          <a:p/>
+        </p:txBody>
+      </p:sp>
       <p:cxnSp>
         <p:nvCxnSpPr>
-          <p:cNvPr id="19" name="milestone.delivery.line"/>
+          <p:cNvPr id="20" name="milestone.delivery.line"/>
           <p:cNvCxnSpPr/>
           <p:nvPr/>
         </p:nvCxnSpPr>
         <p:spPr>
           <a:xfrm>
-            <a:off x="1067034" y="1710690"/>
-            <a:ext cx="9940057" cy="0"/>
+            <a:off x="1432794" y="1777677"/>
+            <a:ext cx="9208537" cy="0"/>
           </a:xfrm>
           <a:prstGeom prst="line">
             <a:avLst/>
@@ -36204,14 +36289,14 @@
       </p:cxnSp>
       <p:sp>
         <p:nvSpPr>
-          <p:cNvPr id="20" name="milestone.delivery.item_1.date"/>
+          <p:cNvPr id="21" name="milestone.delivery.item_1.date"/>
           <p:cNvSpPr txBox="1"/>
           <p:nvPr/>
         </p:nvSpPr>
         <p:spPr>
           <a:xfrm>
-            <a:off x="357030" y="1290066"/>
-            <a:ext cx="1420008" cy="219456"/>
+            <a:off x="929874" y="1411917"/>
+            <a:ext cx="1005840" cy="292608"/>
           </a:xfrm>
           <a:prstGeom prst="rect">
             <a:avLst/>
@@ -36226,25 +36311,25 @@
           <a:p>
             <a:pPr algn="ctr"/>
             <a:r>
-              <a:rPr sz="1200" b="1">
+              <a:rPr sz="1400" b="1">
                 <a:solidFill>
                   <a:srgbClr val="C00000"/>
                 </a:solidFill>
               </a:rPr>
-              <a:t>06-25</a:t>
+              <a:t>2026-06-25</a:t>
             </a:r>
           </a:p>
         </p:txBody>
       </p:sp>
       <p:sp>
         <p:nvSpPr>
-          <p:cNvPr id="21" name="milestone.delivery.item_1.node"/>
+          <p:cNvPr id="22" name="milestone.delivery.item_1.node"/>
           <p:cNvSpPr/>
           <p:nvPr/>
         </p:nvSpPr>
         <p:spPr>
           <a:xfrm>
-            <a:off x="966450" y="1610106"/>
+            <a:off x="1332210" y="1677093"/>
             <a:ext cx="201168" cy="201168"/>
           </a:xfrm>
           <a:prstGeom prst="ellipse">
@@ -36279,55 +36364,14 @@
       </p:sp>
       <p:sp>
         <p:nvSpPr>
-          <p:cNvPr id="22" name="milestone.delivery.item_1.node.inner"/>
-          <p:cNvSpPr/>
-          <p:nvPr/>
-        </p:nvSpPr>
-        <p:spPr>
-          <a:xfrm>
-            <a:off x="1014731" y="1658387"/>
-            <a:ext cx="104606" cy="104606"/>
-          </a:xfrm>
-          <a:prstGeom prst="ellipse">
-            <a:avLst/>
-          </a:prstGeom>
-          <a:solidFill>
-            <a:srgbClr val="FFFFFF"/>
-          </a:solidFill>
-          <a:ln/>
-        </p:spPr>
-        <p:style>
-          <a:lnRef idx="1">
-            <a:schemeClr val="accent1"/>
-          </a:lnRef>
-          <a:fillRef idx="3">
-            <a:schemeClr val="accent1"/>
-          </a:fillRef>
-          <a:effectRef idx="2">
-            <a:schemeClr val="accent1"/>
-          </a:effectRef>
-          <a:fontRef idx="minor">
-            <a:schemeClr val="lt1"/>
-          </a:fontRef>
-        </p:style>
-        <p:txBody>
-          <a:bodyPr rtlCol="0" anchor="ctr"/>
-          <a:lstStyle/>
-          <a:p>
-            <a:pPr algn="ctr"/>
-          </a:p>
-        </p:txBody>
-      </p:sp>
-      <p:sp>
-        <p:nvSpPr>
           <p:cNvPr id="23" name="milestone.delivery.item_1.label"/>
           <p:cNvSpPr txBox="1"/>
           <p:nvPr/>
         </p:nvSpPr>
         <p:spPr>
           <a:xfrm>
-            <a:off x="357030" y="1841449"/>
-            <a:ext cx="1420008" cy="329184"/>
+            <a:off x="775041" y="1850829"/>
+            <a:ext cx="1315505" cy="329184"/>
           </a:xfrm>
           <a:prstGeom prst="rect">
             <a:avLst/>
@@ -36344,8 +36388,9 @@
             <a:r>
               <a:rPr sz="1400" b="1">
                 <a:solidFill>
-                  <a:srgbClr val="666666"/>
+                  <a:srgbClr val="333333"/>
                 </a:solidFill>
+                <a:latin typeface="Microsoft YaHei"/>
               </a:rPr>
               <a:t>前置学习</a:t>
             </a:r>
@@ -36360,8 +36405,8 @@
         </p:nvSpPr>
         <p:spPr>
           <a:xfrm>
-            <a:off x="2013706" y="1290066"/>
-            <a:ext cx="1420008" cy="219456"/>
+            <a:off x="2464630" y="1411917"/>
+            <a:ext cx="1005840" cy="292608"/>
           </a:xfrm>
           <a:prstGeom prst="rect">
             <a:avLst/>
@@ -36376,12 +36421,12 @@
           <a:p>
             <a:pPr algn="ctr"/>
             <a:r>
-              <a:rPr sz="1200" b="1">
+              <a:rPr sz="1400" b="1">
                 <a:solidFill>
                   <a:srgbClr val="C00000"/>
                 </a:solidFill>
               </a:rPr>
-              <a:t>12-10</a:t>
+              <a:t>2025-12-10</a:t>
             </a:r>
           </a:p>
         </p:txBody>
@@ -36394,7 +36439,7 @@
         </p:nvSpPr>
         <p:spPr>
           <a:xfrm>
-            <a:off x="2623126" y="1610106"/>
+            <a:off x="2866966" y="1677093"/>
             <a:ext cx="201168" cy="201168"/>
           </a:xfrm>
           <a:prstGeom prst="ellipse">
@@ -36435,7 +36480,7 @@
         </p:nvSpPr>
         <p:spPr>
           <a:xfrm>
-            <a:off x="2671407" y="1658387"/>
+            <a:off x="2915247" y="1725374"/>
             <a:ext cx="104606" cy="104606"/>
           </a:xfrm>
           <a:prstGeom prst="ellipse">
@@ -36476,8 +36521,8 @@
         </p:nvSpPr>
         <p:spPr>
           <a:xfrm>
-            <a:off x="2013706" y="1841449"/>
-            <a:ext cx="1420008" cy="329184"/>
+            <a:off x="2309797" y="1850829"/>
+            <a:ext cx="1315505" cy="329184"/>
           </a:xfrm>
           <a:prstGeom prst="rect">
             <a:avLst/>
@@ -36496,6 +36541,7 @@
                 <a:solidFill>
                   <a:srgbClr val="666666"/>
                 </a:solidFill>
+                <a:latin typeface="Microsoft YaHei"/>
               </a:rPr>
               <a:t>勘测</a:t>
             </a:r>
@@ -36510,8 +36556,8 @@
         </p:nvSpPr>
         <p:spPr>
           <a:xfrm>
-            <a:off x="3670382" y="1290066"/>
-            <a:ext cx="1420008" cy="219456"/>
+            <a:off x="3999386" y="1411917"/>
+            <a:ext cx="1005840" cy="292608"/>
           </a:xfrm>
           <a:prstGeom prst="rect">
             <a:avLst/>
@@ -36526,12 +36572,12 @@
           <a:p>
             <a:pPr algn="ctr"/>
             <a:r>
-              <a:rPr sz="1200" b="1">
+              <a:rPr sz="1400" b="1">
                 <a:solidFill>
                   <a:srgbClr val="C00000"/>
                 </a:solidFill>
               </a:rPr>
-              <a:t>06-28</a:t>
+              <a:t>2026-06-28</a:t>
             </a:r>
           </a:p>
         </p:txBody>
@@ -36544,7 +36590,7 @@
         </p:nvSpPr>
         <p:spPr>
           <a:xfrm>
-            <a:off x="4279802" y="1610106"/>
+            <a:off x="4401722" y="1677093"/>
             <a:ext cx="201168" cy="201168"/>
           </a:xfrm>
           <a:prstGeom prst="ellipse">
@@ -36585,7 +36631,7 @@
         </p:nvSpPr>
         <p:spPr>
           <a:xfrm>
-            <a:off x="4328083" y="1658387"/>
+            <a:off x="4450003" y="1725374"/>
             <a:ext cx="104606" cy="104606"/>
           </a:xfrm>
           <a:prstGeom prst="ellipse">
@@ -36626,8 +36672,8 @@
         </p:nvSpPr>
         <p:spPr>
           <a:xfrm>
-            <a:off x="3670382" y="1841449"/>
-            <a:ext cx="1420008" cy="329184"/>
+            <a:off x="3844553" y="1850829"/>
+            <a:ext cx="1315505" cy="329184"/>
           </a:xfrm>
           <a:prstGeom prst="rect">
             <a:avLst/>
@@ -36646,6 +36692,7 @@
                 <a:solidFill>
                   <a:srgbClr val="666666"/>
                 </a:solidFill>
+                <a:latin typeface="Microsoft YaHei"/>
               </a:rPr>
               <a:t>设 计</a:t>
             </a:r>
@@ -36660,8 +36707,8 @@
         </p:nvSpPr>
         <p:spPr>
           <a:xfrm>
-            <a:off x="5327058" y="1290066"/>
-            <a:ext cx="1420008" cy="219456"/>
+            <a:off x="5534142" y="1411917"/>
+            <a:ext cx="1005840" cy="292608"/>
           </a:xfrm>
           <a:prstGeom prst="rect">
             <a:avLst/>
@@ -36676,12 +36723,12 @@
           <a:p>
             <a:pPr algn="ctr"/>
             <a:r>
-              <a:rPr sz="1200" b="1">
+              <a:rPr sz="1400" b="1">
                 <a:solidFill>
                   <a:srgbClr val="C00000"/>
                 </a:solidFill>
               </a:rPr>
-              <a:t>06-24</a:t>
+              <a:t>2026-06-24</a:t>
             </a:r>
           </a:p>
         </p:txBody>
@@ -36694,7 +36741,7 @@
         </p:nvSpPr>
         <p:spPr>
           <a:xfrm>
-            <a:off x="5936478" y="1610106"/>
+            <a:off x="5936478" y="1677093"/>
             <a:ext cx="201168" cy="201168"/>
           </a:xfrm>
           <a:prstGeom prst="ellipse">
@@ -36735,7 +36782,7 @@
         </p:nvSpPr>
         <p:spPr>
           <a:xfrm>
-            <a:off x="5984759" y="1658387"/>
+            <a:off x="5984759" y="1725374"/>
             <a:ext cx="104606" cy="104606"/>
           </a:xfrm>
           <a:prstGeom prst="ellipse">
@@ -36776,8 +36823,8 @@
         </p:nvSpPr>
         <p:spPr>
           <a:xfrm>
-            <a:off x="5327058" y="1841449"/>
-            <a:ext cx="1420008" cy="329184"/>
+            <a:off x="5379309" y="1850829"/>
+            <a:ext cx="1315505" cy="329184"/>
           </a:xfrm>
           <a:prstGeom prst="rect">
             <a:avLst/>
@@ -36796,6 +36843,7 @@
                 <a:solidFill>
                   <a:srgbClr val="666666"/>
                 </a:solidFill>
+                <a:latin typeface="Microsoft YaHei"/>
               </a:rPr>
               <a:t>安装</a:t>
             </a:r>
@@ -36810,8 +36858,8 @@
         </p:nvSpPr>
         <p:spPr>
           <a:xfrm>
-            <a:off x="6983735" y="1290066"/>
-            <a:ext cx="1420008" cy="219456"/>
+            <a:off x="7068899" y="1411917"/>
+            <a:ext cx="1005840" cy="292608"/>
           </a:xfrm>
           <a:prstGeom prst="rect">
             <a:avLst/>
@@ -36826,12 +36874,12 @@
           <a:p>
             <a:pPr algn="ctr"/>
             <a:r>
-              <a:rPr sz="1200" b="1">
+              <a:rPr sz="1400" b="1">
                 <a:solidFill>
                   <a:srgbClr val="C00000"/>
                 </a:solidFill>
               </a:rPr>
-              <a:t>07-18</a:t>
+              <a:t>2029-07-18</a:t>
             </a:r>
           </a:p>
         </p:txBody>
@@ -36844,7 +36892,7 @@
         </p:nvSpPr>
         <p:spPr>
           <a:xfrm>
-            <a:off x="7593155" y="1610106"/>
+            <a:off x="7471235" y="1677093"/>
             <a:ext cx="201168" cy="201168"/>
           </a:xfrm>
           <a:prstGeom prst="ellipse">
@@ -36885,7 +36933,7 @@
         </p:nvSpPr>
         <p:spPr>
           <a:xfrm>
-            <a:off x="7641436" y="1658387"/>
+            <a:off x="7519516" y="1725374"/>
             <a:ext cx="104606" cy="104606"/>
           </a:xfrm>
           <a:prstGeom prst="ellipse">
@@ -36926,8 +36974,8 @@
         </p:nvSpPr>
         <p:spPr>
           <a:xfrm>
-            <a:off x="6983735" y="1841449"/>
-            <a:ext cx="1420008" cy="329184"/>
+            <a:off x="6914066" y="1850829"/>
+            <a:ext cx="1315505" cy="329184"/>
           </a:xfrm>
           <a:prstGeom prst="rect">
             <a:avLst/>
@@ -36946,6 +36994,7 @@
                 <a:solidFill>
                   <a:srgbClr val="666666"/>
                 </a:solidFill>
+                <a:latin typeface="Microsoft YaHei"/>
               </a:rPr>
               <a:t>调测</a:t>
             </a:r>
@@ -36960,8 +37009,8 @@
         </p:nvSpPr>
         <p:spPr>
           <a:xfrm>
-            <a:off x="8640411" y="1290066"/>
-            <a:ext cx="1420008" cy="219456"/>
+            <a:off x="8603655" y="1411917"/>
+            <a:ext cx="1005840" cy="292608"/>
           </a:xfrm>
           <a:prstGeom prst="rect">
             <a:avLst/>
@@ -36976,12 +37025,12 @@
           <a:p>
             <a:pPr algn="ctr"/>
             <a:r>
-              <a:rPr sz="1200" b="1">
+              <a:rPr sz="1400" b="1">
                 <a:solidFill>
                   <a:srgbClr val="C00000"/>
                 </a:solidFill>
               </a:rPr>
-              <a:t>07-09</a:t>
+              <a:t>2026-07-09</a:t>
             </a:r>
           </a:p>
         </p:txBody>
@@ -36994,7 +37043,7 @@
         </p:nvSpPr>
         <p:spPr>
           <a:xfrm>
-            <a:off x="9249831" y="1610106"/>
+            <a:off x="9005991" y="1677093"/>
             <a:ext cx="201168" cy="201168"/>
           </a:xfrm>
           <a:prstGeom prst="ellipse">
@@ -37035,7 +37084,7 @@
         </p:nvSpPr>
         <p:spPr>
           <a:xfrm>
-            <a:off x="9298112" y="1658387"/>
+            <a:off x="9054272" y="1725374"/>
             <a:ext cx="104606" cy="104606"/>
           </a:xfrm>
           <a:prstGeom prst="ellipse">
@@ -37076,8 +37125,8 @@
         </p:nvSpPr>
         <p:spPr>
           <a:xfrm>
-            <a:off x="8640411" y="1841449"/>
-            <a:ext cx="1420008" cy="329184"/>
+            <a:off x="8448822" y="1850829"/>
+            <a:ext cx="1315505" cy="329184"/>
           </a:xfrm>
           <a:prstGeom prst="rect">
             <a:avLst/>
@@ -37096,6 +37145,7 @@
                 <a:solidFill>
                   <a:srgbClr val="666666"/>
                 </a:solidFill>
+                <a:latin typeface="Microsoft YaHei"/>
               </a:rPr>
               <a:t>移交&amp;培训</a:t>
             </a:r>
@@ -37110,8 +37160,8 @@
         </p:nvSpPr>
         <p:spPr>
           <a:xfrm>
-            <a:off x="10297087" y="1290066"/>
-            <a:ext cx="1420008" cy="219456"/>
+            <a:off x="10138411" y="1411917"/>
+            <a:ext cx="1005840" cy="292608"/>
           </a:xfrm>
           <a:prstGeom prst="rect">
             <a:avLst/>
@@ -37126,12 +37176,12 @@
           <a:p>
             <a:pPr algn="ctr"/>
             <a:r>
-              <a:rPr sz="1200" b="1">
+              <a:rPr sz="1400" b="1">
                 <a:solidFill>
                   <a:srgbClr val="C00000"/>
                 </a:solidFill>
               </a:rPr>
-              <a:t>12-30</a:t>
+              <a:t>2025-11-28</a:t>
             </a:r>
           </a:p>
         </p:txBody>
@@ -37144,7 +37194,7 @@
         </p:nvSpPr>
         <p:spPr>
           <a:xfrm>
-            <a:off x="10906507" y="1610106"/>
+            <a:off x="10540747" y="1677093"/>
             <a:ext cx="201168" cy="201168"/>
           </a:xfrm>
           <a:prstGeom prst="ellipse">
@@ -37185,7 +37235,7 @@
         </p:nvSpPr>
         <p:spPr>
           <a:xfrm>
-            <a:off x="10954788" y="1658387"/>
+            <a:off x="10589028" y="1725374"/>
             <a:ext cx="104606" cy="104606"/>
           </a:xfrm>
           <a:prstGeom prst="ellipse">
@@ -37226,8 +37276,8 @@
         </p:nvSpPr>
         <p:spPr>
           <a:xfrm>
-            <a:off x="10297087" y="1841449"/>
-            <a:ext cx="1420008" cy="329184"/>
+            <a:off x="9983578" y="1850829"/>
+            <a:ext cx="1315505" cy="329184"/>
           </a:xfrm>
           <a:prstGeom prst="rect">
             <a:avLst/>
@@ -37246,6 +37296,7 @@
                 <a:solidFill>
                   <a:srgbClr val="666666"/>
                 </a:solidFill>
+                <a:latin typeface="Microsoft YaHei"/>
               </a:rPr>
               <a:t>验收</a:t>
             </a:r>
@@ -38216,7 +38267,7 @@
                 <a:cs typeface="Noto Sans SC"/>
                 <a:sym typeface="Noto Sans SC"/>
               </a:rPr>
-              <a:t>1. 开局配置</a:t>
+              <a:t>1. 低阶设计</a:t>
             </a:r>
             <a:r>
               <a:rPr lang="en-US" altLang="zh-CN" sz="1800" b="1" dirty="0">
@@ -38257,7 +38308,7 @@
                 <a:cs typeface="Noto Sans SC"/>
                 <a:sym typeface="Noto Sans SC"/>
               </a:rPr>
-              <a:t>2. 配置检查</a:t>
+              <a:t>2. 入场确认</a:t>
             </a:r>
             <a:r>
               <a:rPr lang="en-US" altLang="zh-CN" sz="1800" b="1" dirty="0">

</xml_diff>

<commit_message>
Support rich text and top issue label styling
</commit_message>
<xml_diff>
--- a/examples/italy_progress_report/preview_replace_report.pptx
+++ b/examples/italy_progress_report/preview_replace_report.pptx
@@ -21256,7 +21256,7 @@
                 <a:cs typeface="Noto Sans SC"/>
                 <a:sym typeface="Noto Sans SC"/>
               </a:rPr>
-              <a:t>项目处于进行中，交付任务与风险跟踪持续推进。</a:t>
+              <a:t>项目处于进行中，调测与验收相关任务持续推进。</a:t>
             </a:r>
             <a:endParaRPr lang="en-US" dirty="0">
               <a:solidFill>
@@ -21350,7 +21350,7 @@
                 <a:cs typeface="Noto Sans SC"/>
                 <a:sym typeface="Noto Sans SC"/>
               </a:rPr>
-              <a:t>关键结论：整体推进中，延期任务需关注。</a:t>
+              <a:t>关键结论：整体推进中，逾期与待分配任务需关注。</a:t>
             </a:r>
             <a:r>
               <a:rPr lang="en-US" altLang="zh-CN" sz="1200" b="0" i="0" u="none" strike="noStrike" dirty="0">
@@ -36304,7 +36304,7 @@
           <a:noFill/>
         </p:spPr>
         <p:txBody>
-          <a:bodyPr wrap="none" lIns="0" rIns="0" tIns="0" bIns="0">
+          <a:bodyPr wrap="none" lIns="0" rIns="0" tIns="0" bIns="0" anchor="ctr">
             <a:spAutoFit/>
           </a:bodyPr>
           <a:lstStyle/>
@@ -36316,7 +36316,7 @@
                   <a:srgbClr val="C00000"/>
                 </a:solidFill>
               </a:rPr>
-              <a:t>2026-06-25</a:t>
+              <a:t>2026-06-28</a:t>
             </a:r>
           </a:p>
         </p:txBody>
@@ -36364,123 +36364,13 @@
       </p:sp>
       <p:sp>
         <p:nvSpPr>
-          <p:cNvPr id="23" name="milestone.delivery.item_1.label"/>
-          <p:cNvSpPr txBox="1"/>
-          <p:nvPr/>
-        </p:nvSpPr>
-        <p:spPr>
-          <a:xfrm>
-            <a:off x="775041" y="1850829"/>
-            <a:ext cx="1315505" cy="329184"/>
-          </a:xfrm>
-          <a:prstGeom prst="rect">
-            <a:avLst/>
-          </a:prstGeom>
-          <a:noFill/>
-        </p:spPr>
-        <p:txBody>
-          <a:bodyPr wrap="none" lIns="0" rIns="0" tIns="0" bIns="0">
-            <a:spAutoFit/>
-          </a:bodyPr>
-          <a:lstStyle/>
-          <a:p>
-            <a:pPr algn="ctr"/>
-            <a:r>
-              <a:rPr sz="1400" b="1">
-                <a:solidFill>
-                  <a:srgbClr val="333333"/>
-                </a:solidFill>
-                <a:latin typeface="Microsoft YaHei"/>
-              </a:rPr>
-              <a:t>前置学习</a:t>
-            </a:r>
-          </a:p>
-        </p:txBody>
-      </p:sp>
-      <p:sp>
-        <p:nvSpPr>
-          <p:cNvPr id="24" name="milestone.delivery.item_2.date"/>
-          <p:cNvSpPr txBox="1"/>
-          <p:nvPr/>
-        </p:nvSpPr>
-        <p:spPr>
-          <a:xfrm>
-            <a:off x="2464630" y="1411917"/>
-            <a:ext cx="1005840" cy="292608"/>
-          </a:xfrm>
-          <a:prstGeom prst="rect">
-            <a:avLst/>
-          </a:prstGeom>
-          <a:noFill/>
-        </p:spPr>
-        <p:txBody>
-          <a:bodyPr wrap="none" lIns="0" rIns="0" tIns="0" bIns="0">
-            <a:spAutoFit/>
-          </a:bodyPr>
-          <a:lstStyle/>
-          <a:p>
-            <a:pPr algn="ctr"/>
-            <a:r>
-              <a:rPr sz="1400" b="1">
-                <a:solidFill>
-                  <a:srgbClr val="C00000"/>
-                </a:solidFill>
-              </a:rPr>
-              <a:t>2025-12-10</a:t>
-            </a:r>
-          </a:p>
-        </p:txBody>
-      </p:sp>
-      <p:sp>
-        <p:nvSpPr>
-          <p:cNvPr id="25" name="milestone.delivery.item_2.node"/>
+          <p:cNvPr id="23" name="milestone.delivery.item_1.node.inner"/>
           <p:cNvSpPr/>
           <p:nvPr/>
         </p:nvSpPr>
         <p:spPr>
           <a:xfrm>
-            <a:off x="2866966" y="1677093"/>
-            <a:ext cx="201168" cy="201168"/>
-          </a:xfrm>
-          <a:prstGeom prst="ellipse">
-            <a:avLst/>
-          </a:prstGeom>
-          <a:solidFill>
-            <a:srgbClr val="0052CC"/>
-          </a:solidFill>
-          <a:ln/>
-        </p:spPr>
-        <p:style>
-          <a:lnRef idx="1">
-            <a:schemeClr val="accent1"/>
-          </a:lnRef>
-          <a:fillRef idx="3">
-            <a:schemeClr val="accent1"/>
-          </a:fillRef>
-          <a:effectRef idx="2">
-            <a:schemeClr val="accent1"/>
-          </a:effectRef>
-          <a:fontRef idx="minor">
-            <a:schemeClr val="lt1"/>
-          </a:fontRef>
-        </p:style>
-        <p:txBody>
-          <a:bodyPr rtlCol="0" anchor="ctr"/>
-          <a:lstStyle/>
-          <a:p>
-            <a:pPr algn="ctr"/>
-          </a:p>
-        </p:txBody>
-      </p:sp>
-      <p:sp>
-        <p:nvSpPr>
-          <p:cNvPr id="26" name="milestone.delivery.item_2.node.inner"/>
-          <p:cNvSpPr/>
-          <p:nvPr/>
-        </p:nvSpPr>
-        <p:spPr>
-          <a:xfrm>
-            <a:off x="2915247" y="1725374"/>
+            <a:off x="1380491" y="1725374"/>
             <a:ext cx="104606" cy="104606"/>
           </a:xfrm>
           <a:prstGeom prst="ellipse">
@@ -36515,14 +36405,14 @@
       </p:sp>
       <p:sp>
         <p:nvSpPr>
-          <p:cNvPr id="27" name="milestone.delivery.item_2.label"/>
+          <p:cNvPr id="24" name="milestone.delivery.item_1.label"/>
           <p:cNvSpPr txBox="1"/>
           <p:nvPr/>
         </p:nvSpPr>
         <p:spPr>
           <a:xfrm>
-            <a:off x="2309797" y="1850829"/>
-            <a:ext cx="1315505" cy="329184"/>
+            <a:off x="-869340" y="1850829"/>
+            <a:ext cx="4604268" cy="329184"/>
           </a:xfrm>
           <a:prstGeom prst="rect">
             <a:avLst/>
@@ -36530,7 +36420,7 @@
           <a:noFill/>
         </p:spPr>
         <p:txBody>
-          <a:bodyPr wrap="none" lIns="0" rIns="0" tIns="0" bIns="0">
+          <a:bodyPr wrap="none" lIns="0" rIns="0" tIns="0" bIns="0" anchor="ctr">
             <a:spAutoFit/>
           </a:bodyPr>
           <a:lstStyle/>
@@ -36543,618 +36433,14 @@
                 </a:solidFill>
                 <a:latin typeface="Microsoft YaHei"/>
               </a:rPr>
-              <a:t>勘测</a:t>
+              <a:t>设计</a:t>
             </a:r>
           </a:p>
         </p:txBody>
       </p:sp>
       <p:sp>
         <p:nvSpPr>
-          <p:cNvPr id="28" name="milestone.delivery.item_3.date"/>
-          <p:cNvSpPr txBox="1"/>
-          <p:nvPr/>
-        </p:nvSpPr>
-        <p:spPr>
-          <a:xfrm>
-            <a:off x="3999386" y="1411917"/>
-            <a:ext cx="1005840" cy="292608"/>
-          </a:xfrm>
-          <a:prstGeom prst="rect">
-            <a:avLst/>
-          </a:prstGeom>
-          <a:noFill/>
-        </p:spPr>
-        <p:txBody>
-          <a:bodyPr wrap="none" lIns="0" rIns="0" tIns="0" bIns="0">
-            <a:spAutoFit/>
-          </a:bodyPr>
-          <a:lstStyle/>
-          <a:p>
-            <a:pPr algn="ctr"/>
-            <a:r>
-              <a:rPr sz="1400" b="1">
-                <a:solidFill>
-                  <a:srgbClr val="C00000"/>
-                </a:solidFill>
-              </a:rPr>
-              <a:t>2026-06-28</a:t>
-            </a:r>
-          </a:p>
-        </p:txBody>
-      </p:sp>
-      <p:sp>
-        <p:nvSpPr>
-          <p:cNvPr id="29" name="milestone.delivery.item_3.node"/>
-          <p:cNvSpPr/>
-          <p:nvPr/>
-        </p:nvSpPr>
-        <p:spPr>
-          <a:xfrm>
-            <a:off x="4401722" y="1677093"/>
-            <a:ext cx="201168" cy="201168"/>
-          </a:xfrm>
-          <a:prstGeom prst="ellipse">
-            <a:avLst/>
-          </a:prstGeom>
-          <a:solidFill>
-            <a:srgbClr val="0052CC"/>
-          </a:solidFill>
-          <a:ln/>
-        </p:spPr>
-        <p:style>
-          <a:lnRef idx="1">
-            <a:schemeClr val="accent1"/>
-          </a:lnRef>
-          <a:fillRef idx="3">
-            <a:schemeClr val="accent1"/>
-          </a:fillRef>
-          <a:effectRef idx="2">
-            <a:schemeClr val="accent1"/>
-          </a:effectRef>
-          <a:fontRef idx="minor">
-            <a:schemeClr val="lt1"/>
-          </a:fontRef>
-        </p:style>
-        <p:txBody>
-          <a:bodyPr rtlCol="0" anchor="ctr"/>
-          <a:lstStyle/>
-          <a:p>
-            <a:pPr algn="ctr"/>
-          </a:p>
-        </p:txBody>
-      </p:sp>
-      <p:sp>
-        <p:nvSpPr>
-          <p:cNvPr id="30" name="milestone.delivery.item_3.node.inner"/>
-          <p:cNvSpPr/>
-          <p:nvPr/>
-        </p:nvSpPr>
-        <p:spPr>
-          <a:xfrm>
-            <a:off x="4450003" y="1725374"/>
-            <a:ext cx="104606" cy="104606"/>
-          </a:xfrm>
-          <a:prstGeom prst="ellipse">
-            <a:avLst/>
-          </a:prstGeom>
-          <a:solidFill>
-            <a:srgbClr val="FFFFFF"/>
-          </a:solidFill>
-          <a:ln/>
-        </p:spPr>
-        <p:style>
-          <a:lnRef idx="1">
-            <a:schemeClr val="accent1"/>
-          </a:lnRef>
-          <a:fillRef idx="3">
-            <a:schemeClr val="accent1"/>
-          </a:fillRef>
-          <a:effectRef idx="2">
-            <a:schemeClr val="accent1"/>
-          </a:effectRef>
-          <a:fontRef idx="minor">
-            <a:schemeClr val="lt1"/>
-          </a:fontRef>
-        </p:style>
-        <p:txBody>
-          <a:bodyPr rtlCol="0" anchor="ctr"/>
-          <a:lstStyle/>
-          <a:p>
-            <a:pPr algn="ctr"/>
-          </a:p>
-        </p:txBody>
-      </p:sp>
-      <p:sp>
-        <p:nvSpPr>
-          <p:cNvPr id="31" name="milestone.delivery.item_3.label"/>
-          <p:cNvSpPr txBox="1"/>
-          <p:nvPr/>
-        </p:nvSpPr>
-        <p:spPr>
-          <a:xfrm>
-            <a:off x="3844553" y="1850829"/>
-            <a:ext cx="1315505" cy="329184"/>
-          </a:xfrm>
-          <a:prstGeom prst="rect">
-            <a:avLst/>
-          </a:prstGeom>
-          <a:noFill/>
-        </p:spPr>
-        <p:txBody>
-          <a:bodyPr wrap="none" lIns="0" rIns="0" tIns="0" bIns="0">
-            <a:spAutoFit/>
-          </a:bodyPr>
-          <a:lstStyle/>
-          <a:p>
-            <a:pPr algn="ctr"/>
-            <a:r>
-              <a:rPr sz="1400" b="1">
-                <a:solidFill>
-                  <a:srgbClr val="666666"/>
-                </a:solidFill>
-                <a:latin typeface="Microsoft YaHei"/>
-              </a:rPr>
-              <a:t>设 计</a:t>
-            </a:r>
-          </a:p>
-        </p:txBody>
-      </p:sp>
-      <p:sp>
-        <p:nvSpPr>
-          <p:cNvPr id="32" name="milestone.delivery.item_4.date"/>
-          <p:cNvSpPr txBox="1"/>
-          <p:nvPr/>
-        </p:nvSpPr>
-        <p:spPr>
-          <a:xfrm>
-            <a:off x="5534142" y="1411917"/>
-            <a:ext cx="1005840" cy="292608"/>
-          </a:xfrm>
-          <a:prstGeom prst="rect">
-            <a:avLst/>
-          </a:prstGeom>
-          <a:noFill/>
-        </p:spPr>
-        <p:txBody>
-          <a:bodyPr wrap="none" lIns="0" rIns="0" tIns="0" bIns="0">
-            <a:spAutoFit/>
-          </a:bodyPr>
-          <a:lstStyle/>
-          <a:p>
-            <a:pPr algn="ctr"/>
-            <a:r>
-              <a:rPr sz="1400" b="1">
-                <a:solidFill>
-                  <a:srgbClr val="C00000"/>
-                </a:solidFill>
-              </a:rPr>
-              <a:t>2026-06-24</a:t>
-            </a:r>
-          </a:p>
-        </p:txBody>
-      </p:sp>
-      <p:sp>
-        <p:nvSpPr>
-          <p:cNvPr id="33" name="milestone.delivery.item_4.node"/>
-          <p:cNvSpPr/>
-          <p:nvPr/>
-        </p:nvSpPr>
-        <p:spPr>
-          <a:xfrm>
-            <a:off x="5936478" y="1677093"/>
-            <a:ext cx="201168" cy="201168"/>
-          </a:xfrm>
-          <a:prstGeom prst="ellipse">
-            <a:avLst/>
-          </a:prstGeom>
-          <a:solidFill>
-            <a:srgbClr val="0052CC"/>
-          </a:solidFill>
-          <a:ln/>
-        </p:spPr>
-        <p:style>
-          <a:lnRef idx="1">
-            <a:schemeClr val="accent1"/>
-          </a:lnRef>
-          <a:fillRef idx="3">
-            <a:schemeClr val="accent1"/>
-          </a:fillRef>
-          <a:effectRef idx="2">
-            <a:schemeClr val="accent1"/>
-          </a:effectRef>
-          <a:fontRef idx="minor">
-            <a:schemeClr val="lt1"/>
-          </a:fontRef>
-        </p:style>
-        <p:txBody>
-          <a:bodyPr rtlCol="0" anchor="ctr"/>
-          <a:lstStyle/>
-          <a:p>
-            <a:pPr algn="ctr"/>
-          </a:p>
-        </p:txBody>
-      </p:sp>
-      <p:sp>
-        <p:nvSpPr>
-          <p:cNvPr id="34" name="milestone.delivery.item_4.node.inner"/>
-          <p:cNvSpPr/>
-          <p:nvPr/>
-        </p:nvSpPr>
-        <p:spPr>
-          <a:xfrm>
-            <a:off x="5984759" y="1725374"/>
-            <a:ext cx="104606" cy="104606"/>
-          </a:xfrm>
-          <a:prstGeom prst="ellipse">
-            <a:avLst/>
-          </a:prstGeom>
-          <a:solidFill>
-            <a:srgbClr val="FFFFFF"/>
-          </a:solidFill>
-          <a:ln/>
-        </p:spPr>
-        <p:style>
-          <a:lnRef idx="1">
-            <a:schemeClr val="accent1"/>
-          </a:lnRef>
-          <a:fillRef idx="3">
-            <a:schemeClr val="accent1"/>
-          </a:fillRef>
-          <a:effectRef idx="2">
-            <a:schemeClr val="accent1"/>
-          </a:effectRef>
-          <a:fontRef idx="minor">
-            <a:schemeClr val="lt1"/>
-          </a:fontRef>
-        </p:style>
-        <p:txBody>
-          <a:bodyPr rtlCol="0" anchor="ctr"/>
-          <a:lstStyle/>
-          <a:p>
-            <a:pPr algn="ctr"/>
-          </a:p>
-        </p:txBody>
-      </p:sp>
-      <p:sp>
-        <p:nvSpPr>
-          <p:cNvPr id="35" name="milestone.delivery.item_4.label"/>
-          <p:cNvSpPr txBox="1"/>
-          <p:nvPr/>
-        </p:nvSpPr>
-        <p:spPr>
-          <a:xfrm>
-            <a:off x="5379309" y="1850829"/>
-            <a:ext cx="1315505" cy="329184"/>
-          </a:xfrm>
-          <a:prstGeom prst="rect">
-            <a:avLst/>
-          </a:prstGeom>
-          <a:noFill/>
-        </p:spPr>
-        <p:txBody>
-          <a:bodyPr wrap="none" lIns="0" rIns="0" tIns="0" bIns="0">
-            <a:spAutoFit/>
-          </a:bodyPr>
-          <a:lstStyle/>
-          <a:p>
-            <a:pPr algn="ctr"/>
-            <a:r>
-              <a:rPr sz="1400" b="1">
-                <a:solidFill>
-                  <a:srgbClr val="666666"/>
-                </a:solidFill>
-                <a:latin typeface="Microsoft YaHei"/>
-              </a:rPr>
-              <a:t>安装</a:t>
-            </a:r>
-          </a:p>
-        </p:txBody>
-      </p:sp>
-      <p:sp>
-        <p:nvSpPr>
-          <p:cNvPr id="36" name="milestone.delivery.item_5.date"/>
-          <p:cNvSpPr txBox="1"/>
-          <p:nvPr/>
-        </p:nvSpPr>
-        <p:spPr>
-          <a:xfrm>
-            <a:off x="7068899" y="1411917"/>
-            <a:ext cx="1005840" cy="292608"/>
-          </a:xfrm>
-          <a:prstGeom prst="rect">
-            <a:avLst/>
-          </a:prstGeom>
-          <a:noFill/>
-        </p:spPr>
-        <p:txBody>
-          <a:bodyPr wrap="none" lIns="0" rIns="0" tIns="0" bIns="0">
-            <a:spAutoFit/>
-          </a:bodyPr>
-          <a:lstStyle/>
-          <a:p>
-            <a:pPr algn="ctr"/>
-            <a:r>
-              <a:rPr sz="1400" b="1">
-                <a:solidFill>
-                  <a:srgbClr val="C00000"/>
-                </a:solidFill>
-              </a:rPr>
-              <a:t>2029-07-18</a:t>
-            </a:r>
-          </a:p>
-        </p:txBody>
-      </p:sp>
-      <p:sp>
-        <p:nvSpPr>
-          <p:cNvPr id="37" name="milestone.delivery.item_5.node"/>
-          <p:cNvSpPr/>
-          <p:nvPr/>
-        </p:nvSpPr>
-        <p:spPr>
-          <a:xfrm>
-            <a:off x="7471235" y="1677093"/>
-            <a:ext cx="201168" cy="201168"/>
-          </a:xfrm>
-          <a:prstGeom prst="ellipse">
-            <a:avLst/>
-          </a:prstGeom>
-          <a:solidFill>
-            <a:srgbClr val="0052CC"/>
-          </a:solidFill>
-          <a:ln/>
-        </p:spPr>
-        <p:style>
-          <a:lnRef idx="1">
-            <a:schemeClr val="accent1"/>
-          </a:lnRef>
-          <a:fillRef idx="3">
-            <a:schemeClr val="accent1"/>
-          </a:fillRef>
-          <a:effectRef idx="2">
-            <a:schemeClr val="accent1"/>
-          </a:effectRef>
-          <a:fontRef idx="minor">
-            <a:schemeClr val="lt1"/>
-          </a:fontRef>
-        </p:style>
-        <p:txBody>
-          <a:bodyPr rtlCol="0" anchor="ctr"/>
-          <a:lstStyle/>
-          <a:p>
-            <a:pPr algn="ctr"/>
-          </a:p>
-        </p:txBody>
-      </p:sp>
-      <p:sp>
-        <p:nvSpPr>
-          <p:cNvPr id="38" name="milestone.delivery.item_5.node.inner"/>
-          <p:cNvSpPr/>
-          <p:nvPr/>
-        </p:nvSpPr>
-        <p:spPr>
-          <a:xfrm>
-            <a:off x="7519516" y="1725374"/>
-            <a:ext cx="104606" cy="104606"/>
-          </a:xfrm>
-          <a:prstGeom prst="ellipse">
-            <a:avLst/>
-          </a:prstGeom>
-          <a:solidFill>
-            <a:srgbClr val="FFFFFF"/>
-          </a:solidFill>
-          <a:ln/>
-        </p:spPr>
-        <p:style>
-          <a:lnRef idx="1">
-            <a:schemeClr val="accent1"/>
-          </a:lnRef>
-          <a:fillRef idx="3">
-            <a:schemeClr val="accent1"/>
-          </a:fillRef>
-          <a:effectRef idx="2">
-            <a:schemeClr val="accent1"/>
-          </a:effectRef>
-          <a:fontRef idx="minor">
-            <a:schemeClr val="lt1"/>
-          </a:fontRef>
-        </p:style>
-        <p:txBody>
-          <a:bodyPr rtlCol="0" anchor="ctr"/>
-          <a:lstStyle/>
-          <a:p>
-            <a:pPr algn="ctr"/>
-          </a:p>
-        </p:txBody>
-      </p:sp>
-      <p:sp>
-        <p:nvSpPr>
-          <p:cNvPr id="39" name="milestone.delivery.item_5.label"/>
-          <p:cNvSpPr txBox="1"/>
-          <p:nvPr/>
-        </p:nvSpPr>
-        <p:spPr>
-          <a:xfrm>
-            <a:off x="6914066" y="1850829"/>
-            <a:ext cx="1315505" cy="329184"/>
-          </a:xfrm>
-          <a:prstGeom prst="rect">
-            <a:avLst/>
-          </a:prstGeom>
-          <a:noFill/>
-        </p:spPr>
-        <p:txBody>
-          <a:bodyPr wrap="none" lIns="0" rIns="0" tIns="0" bIns="0">
-            <a:spAutoFit/>
-          </a:bodyPr>
-          <a:lstStyle/>
-          <a:p>
-            <a:pPr algn="ctr"/>
-            <a:r>
-              <a:rPr sz="1400" b="1">
-                <a:solidFill>
-                  <a:srgbClr val="666666"/>
-                </a:solidFill>
-                <a:latin typeface="Microsoft YaHei"/>
-              </a:rPr>
-              <a:t>调测</a:t>
-            </a:r>
-          </a:p>
-        </p:txBody>
-      </p:sp>
-      <p:sp>
-        <p:nvSpPr>
-          <p:cNvPr id="40" name="milestone.delivery.item_6.date"/>
-          <p:cNvSpPr txBox="1"/>
-          <p:nvPr/>
-        </p:nvSpPr>
-        <p:spPr>
-          <a:xfrm>
-            <a:off x="8603655" y="1411917"/>
-            <a:ext cx="1005840" cy="292608"/>
-          </a:xfrm>
-          <a:prstGeom prst="rect">
-            <a:avLst/>
-          </a:prstGeom>
-          <a:noFill/>
-        </p:spPr>
-        <p:txBody>
-          <a:bodyPr wrap="none" lIns="0" rIns="0" tIns="0" bIns="0">
-            <a:spAutoFit/>
-          </a:bodyPr>
-          <a:lstStyle/>
-          <a:p>
-            <a:pPr algn="ctr"/>
-            <a:r>
-              <a:rPr sz="1400" b="1">
-                <a:solidFill>
-                  <a:srgbClr val="C00000"/>
-                </a:solidFill>
-              </a:rPr>
-              <a:t>2026-07-09</a:t>
-            </a:r>
-          </a:p>
-        </p:txBody>
-      </p:sp>
-      <p:sp>
-        <p:nvSpPr>
-          <p:cNvPr id="41" name="milestone.delivery.item_6.node"/>
-          <p:cNvSpPr/>
-          <p:nvPr/>
-        </p:nvSpPr>
-        <p:spPr>
-          <a:xfrm>
-            <a:off x="9005991" y="1677093"/>
-            <a:ext cx="201168" cy="201168"/>
-          </a:xfrm>
-          <a:prstGeom prst="ellipse">
-            <a:avLst/>
-          </a:prstGeom>
-          <a:solidFill>
-            <a:srgbClr val="0052CC"/>
-          </a:solidFill>
-          <a:ln/>
-        </p:spPr>
-        <p:style>
-          <a:lnRef idx="1">
-            <a:schemeClr val="accent1"/>
-          </a:lnRef>
-          <a:fillRef idx="3">
-            <a:schemeClr val="accent1"/>
-          </a:fillRef>
-          <a:effectRef idx="2">
-            <a:schemeClr val="accent1"/>
-          </a:effectRef>
-          <a:fontRef idx="minor">
-            <a:schemeClr val="lt1"/>
-          </a:fontRef>
-        </p:style>
-        <p:txBody>
-          <a:bodyPr rtlCol="0" anchor="ctr"/>
-          <a:lstStyle/>
-          <a:p>
-            <a:pPr algn="ctr"/>
-          </a:p>
-        </p:txBody>
-      </p:sp>
-      <p:sp>
-        <p:nvSpPr>
-          <p:cNvPr id="42" name="milestone.delivery.item_6.node.inner"/>
-          <p:cNvSpPr/>
-          <p:nvPr/>
-        </p:nvSpPr>
-        <p:spPr>
-          <a:xfrm>
-            <a:off x="9054272" y="1725374"/>
-            <a:ext cx="104606" cy="104606"/>
-          </a:xfrm>
-          <a:prstGeom prst="ellipse">
-            <a:avLst/>
-          </a:prstGeom>
-          <a:solidFill>
-            <a:srgbClr val="FFFFFF"/>
-          </a:solidFill>
-          <a:ln/>
-        </p:spPr>
-        <p:style>
-          <a:lnRef idx="1">
-            <a:schemeClr val="accent1"/>
-          </a:lnRef>
-          <a:fillRef idx="3">
-            <a:schemeClr val="accent1"/>
-          </a:fillRef>
-          <a:effectRef idx="2">
-            <a:schemeClr val="accent1"/>
-          </a:effectRef>
-          <a:fontRef idx="minor">
-            <a:schemeClr val="lt1"/>
-          </a:fontRef>
-        </p:style>
-        <p:txBody>
-          <a:bodyPr rtlCol="0" anchor="ctr"/>
-          <a:lstStyle/>
-          <a:p>
-            <a:pPr algn="ctr"/>
-          </a:p>
-        </p:txBody>
-      </p:sp>
-      <p:sp>
-        <p:nvSpPr>
-          <p:cNvPr id="43" name="milestone.delivery.item_6.label"/>
-          <p:cNvSpPr txBox="1"/>
-          <p:nvPr/>
-        </p:nvSpPr>
-        <p:spPr>
-          <a:xfrm>
-            <a:off x="8448822" y="1850829"/>
-            <a:ext cx="1315505" cy="329184"/>
-          </a:xfrm>
-          <a:prstGeom prst="rect">
-            <a:avLst/>
-          </a:prstGeom>
-          <a:noFill/>
-        </p:spPr>
-        <p:txBody>
-          <a:bodyPr wrap="none" lIns="0" rIns="0" tIns="0" bIns="0">
-            <a:spAutoFit/>
-          </a:bodyPr>
-          <a:lstStyle/>
-          <a:p>
-            <a:pPr algn="ctr"/>
-            <a:r>
-              <a:rPr sz="1400" b="1">
-                <a:solidFill>
-                  <a:srgbClr val="666666"/>
-                </a:solidFill>
-                <a:latin typeface="Microsoft YaHei"/>
-              </a:rPr>
-              <a:t>移交&amp;培训</a:t>
-            </a:r>
-          </a:p>
-        </p:txBody>
-      </p:sp>
-      <p:sp>
-        <p:nvSpPr>
-          <p:cNvPr id="44" name="milestone.delivery.item_7.date"/>
+          <p:cNvPr id="25" name="milestone.delivery.item_2.date"/>
           <p:cNvSpPr txBox="1"/>
           <p:nvPr/>
         </p:nvSpPr>
@@ -37169,7 +36455,7 @@
           <a:noFill/>
         </p:spPr>
         <p:txBody>
-          <a:bodyPr wrap="none" lIns="0" rIns="0" tIns="0" bIns="0">
+          <a:bodyPr wrap="none" lIns="0" rIns="0" tIns="0" bIns="0" anchor="ctr">
             <a:spAutoFit/>
           </a:bodyPr>
           <a:lstStyle/>
@@ -37181,14 +36467,14 @@
                   <a:srgbClr val="C00000"/>
                 </a:solidFill>
               </a:rPr>
-              <a:t>2025-11-28</a:t>
+              <a:t>2026-07-05</a:t>
             </a:r>
           </a:p>
         </p:txBody>
       </p:sp>
       <p:sp>
         <p:nvSpPr>
-          <p:cNvPr id="45" name="milestone.delivery.item_7.node"/>
+          <p:cNvPr id="26" name="milestone.delivery.item_2.node"/>
           <p:cNvSpPr/>
           <p:nvPr/>
         </p:nvSpPr>
@@ -37229,7 +36515,7 @@
       </p:sp>
       <p:sp>
         <p:nvSpPr>
-          <p:cNvPr id="46" name="milestone.delivery.item_7.node.inner"/>
+          <p:cNvPr id="27" name="milestone.delivery.item_2.node.inner"/>
           <p:cNvSpPr/>
           <p:nvPr/>
         </p:nvSpPr>
@@ -37270,14 +36556,14 @@
       </p:sp>
       <p:sp>
         <p:nvSpPr>
-          <p:cNvPr id="47" name="milestone.delivery.item_7.label"/>
+          <p:cNvPr id="28" name="milestone.delivery.item_2.label"/>
           <p:cNvSpPr txBox="1"/>
           <p:nvPr/>
         </p:nvSpPr>
         <p:spPr>
           <a:xfrm>
-            <a:off x="9983578" y="1850829"/>
-            <a:ext cx="1315505" cy="329184"/>
+            <a:off x="8339197" y="1850829"/>
+            <a:ext cx="4604268" cy="329184"/>
           </a:xfrm>
           <a:prstGeom prst="rect">
             <a:avLst/>
@@ -37285,7 +36571,7 @@
           <a:noFill/>
         </p:spPr>
         <p:txBody>
-          <a:bodyPr wrap="none" lIns="0" rIns="0" tIns="0" bIns="0">
+          <a:bodyPr wrap="none" lIns="0" rIns="0" tIns="0" bIns="0" anchor="ctr">
             <a:spAutoFit/>
           </a:bodyPr>
           <a:lstStyle/>
@@ -37590,7 +36876,15 @@
                   <a:srgbClr val="0052CC"/>
                 </a:solidFill>
               </a:rPr>
-              <a:t>问题描述：项目开工25天后，仍未发送开工报告</a:t>
+              <a:t>问题描述：</a:t>
+            </a:r>
+            <a:r>
+              <a:rPr sz="1300" b="0">
+                <a:solidFill>
+                  <a:srgbClr val="333333"/>
+                </a:solidFill>
+              </a:rPr>
+              <a:t>项目开工25天后，仍未发送开工报告</a:t>
             </a:r>
           </a:p>
         </p:txBody>
@@ -37623,7 +36917,15 @@
                   <a:srgbClr val="0052CC"/>
                 </a:solidFill>
               </a:rPr>
-              <a:t>解决措施与进展：待补充处理措施</a:t>
+              <a:t>解决措施与进展：</a:t>
+            </a:r>
+            <a:r>
+              <a:rPr sz="1300" b="0">
+                <a:solidFill>
+                  <a:srgbClr val="333333"/>
+                </a:solidFill>
+              </a:rPr>
+              <a:t>待补充处理措施</a:t>
             </a:r>
           </a:p>
         </p:txBody>
@@ -37812,7 +37114,15 @@
                   <a:srgbClr val="0052CC"/>
                 </a:solidFill>
               </a:rPr>
-              <a:t>问题描述：创建时间2026-06-02 09:04:00，当前进展123456</a:t>
+              <a:t>问题描述：</a:t>
+            </a:r>
+            <a:r>
+              <a:rPr sz="1300" b="0">
+                <a:solidFill>
+                  <a:srgbClr val="333333"/>
+                </a:solidFill>
+              </a:rPr>
+              <a:t>创建时间2026-06-02 09:04:00，当前进展123456</a:t>
             </a:r>
           </a:p>
         </p:txBody>
@@ -37845,7 +37155,15 @@
                   <a:srgbClr val="0052CC"/>
                 </a:solidFill>
               </a:rPr>
-              <a:t>解决措施与进展：待补充处理措施</a:t>
+              <a:t>解决措施与进展：</a:t>
+            </a:r>
+            <a:r>
+              <a:rPr sz="1300" b="0">
+                <a:solidFill>
+                  <a:srgbClr val="333333"/>
+                </a:solidFill>
+              </a:rPr>
+              <a:t>待补充处理措施</a:t>
             </a:r>
           </a:p>
         </p:txBody>
@@ -38034,7 +37352,15 @@
                   <a:srgbClr val="0052CC"/>
                 </a:solidFill>
               </a:rPr>
-              <a:t>问题描述：创建时间2026-06-02 14:53:00，当前进展123</a:t>
+              <a:t>问题描述：</a:t>
+            </a:r>
+            <a:r>
+              <a:rPr sz="1300" b="0">
+                <a:solidFill>
+                  <a:srgbClr val="333333"/>
+                </a:solidFill>
+              </a:rPr>
+              <a:t>创建时间2026-06-02 14:53:00，当前进展123</a:t>
             </a:r>
           </a:p>
         </p:txBody>
@@ -38067,7 +37393,15 @@
                   <a:srgbClr val="0052CC"/>
                 </a:solidFill>
               </a:rPr>
-              <a:t>解决措施与进展：待补充处理措施</a:t>
+              <a:t>解决措施与进展：</a:t>
+            </a:r>
+            <a:r>
+              <a:rPr sz="1300" b="0">
+                <a:solidFill>
+                  <a:srgbClr val="333333"/>
+                </a:solidFill>
+              </a:rPr>
+              <a:t>待补充处理措施</a:t>
             </a:r>
           </a:p>
         </p:txBody>
@@ -38267,7 +37601,7 @@
                 <a:cs typeface="Noto Sans SC"/>
                 <a:sym typeface="Noto Sans SC"/>
               </a:rPr>
-              <a:t>1. 低阶设计</a:t>
+              <a:t>1. 完成配置检查</a:t>
             </a:r>
             <a:r>
               <a:rPr lang="en-US" altLang="zh-CN" sz="1800" b="1" dirty="0">
@@ -38308,7 +37642,7 @@
                 <a:cs typeface="Noto Sans SC"/>
                 <a:sym typeface="Noto Sans SC"/>
               </a:rPr>
-              <a:t>2. 入场确认</a:t>
+              <a:t>2. 推进技能传递</a:t>
             </a:r>
             <a:r>
               <a:rPr lang="en-US" altLang="zh-CN" sz="1800" b="1" dirty="0">

</xml_diff>